<commit_message>
Live URL on slide 1 + slide 7 + README headline
Vercel deployment confirmed live at https://canary-psi.vercel.app —
all 6 dashboard routes return 200, including /scan which makes a real
call to the Modal endpoint and returns the per-cohort breakdown end
to end.

Slide 1 footer: 'Live demo: canary-psi.vercel.app · Code: github.com/...'
Slide 7 footer: 'Try it: canary-psi.vercel.app/scan · Code: ... · Tag: ...'
README first line: live demo + scan + Modal endpoint URLs surfaced.

The audience on May 7 can now open the deck PDF, see the URL, type it
into a phone, and try a live scan against the same models the report
talks about.
</commit_message>
<xml_diff>
--- a/reports/canary_deck.pptx
+++ b/reports/canary_deck.pptx
@@ -1710,6 +1710,48 @@
             <a:r>
               <a:rPr lang="en-US" sz="1100" dirty="0">
                 <a:solidFill>
+                  <a:srgbClr val="CFD8E8"/>
+                </a:solidFill>
+                <a:latin typeface="Calibri" pitchFamily="34" charset="0"/>
+                <a:ea typeface="Calibri" pitchFamily="34" charset="-122"/>
+                <a:cs typeface="Calibri" pitchFamily="34" charset="-120"/>
+              </a:rPr>
+              <a:t>Live demo: </a:t>
+            </a:r>
+            <a:pPr indent="0" marL="0">
+              <a:buNone/>
+            </a:pPr>
+            <a:r>
+              <a:rPr lang="en-US" sz="1100" b="1" dirty="0">
+                <a:solidFill>
+                  <a:srgbClr val="D4A017"/>
+                </a:solidFill>
+                <a:latin typeface="Calibri" pitchFamily="34" charset="0"/>
+                <a:ea typeface="Calibri" pitchFamily="34" charset="-122"/>
+                <a:cs typeface="Calibri" pitchFamily="34" charset="-120"/>
+              </a:rPr>
+              <a:t>canary-psi.vercel.app</a:t>
+            </a:r>
+            <a:pPr indent="0" marL="0">
+              <a:buNone/>
+            </a:pPr>
+            <a:r>
+              <a:rPr lang="en-US" sz="1100" dirty="0">
+                <a:solidFill>
+                  <a:srgbClr val="CFD8E8"/>
+                </a:solidFill>
+                <a:latin typeface="Calibri" pitchFamily="34" charset="0"/>
+                <a:ea typeface="Calibri" pitchFamily="34" charset="-122"/>
+                <a:cs typeface="Calibri" pitchFamily="34" charset="-120"/>
+              </a:rPr>
+              <a:t>    ·    Code: </a:t>
+            </a:r>
+            <a:pPr indent="0" marL="0">
+              <a:buNone/>
+            </a:pPr>
+            <a:r>
+              <a:rPr lang="en-US" sz="1100" dirty="0">
+                <a:solidFill>
                   <a:srgbClr val="D4A017"/>
                 </a:solidFill>
                 <a:latin typeface="Calibri" pitchFamily="34" charset="0"/>
@@ -7980,7 +8022,7 @@
               <a:buNone/>
             </a:pPr>
             <a:r>
-              <a:rPr lang="en-US" sz="1300" dirty="0">
+              <a:rPr lang="en-US" sz="1200" dirty="0">
                 <a:solidFill>
                   <a:srgbClr val="CFD8E8"/>
                 </a:solidFill>
@@ -7988,13 +8030,13 @@
                 <a:ea typeface="Calibri" pitchFamily="34" charset="-122"/>
                 <a:cs typeface="Calibri" pitchFamily="34" charset="-120"/>
               </a:rPr>
-              <a:t>Code &amp; data:  </a:t>
+              <a:t>Try it:  </a:t>
             </a:r>
             <a:pPr indent="0" marL="0">
               <a:buNone/>
             </a:pPr>
             <a:r>
-              <a:rPr lang="en-US" sz="1300" b="1" dirty="0">
+              <a:rPr lang="en-US" sz="1200" b="1" dirty="0">
                 <a:solidFill>
                   <a:srgbClr val="D4A017"/>
                 </a:solidFill>
@@ -8002,13 +8044,13 @@
                 <a:ea typeface="Calibri" pitchFamily="34" charset="-122"/>
                 <a:cs typeface="Calibri" pitchFamily="34" charset="-120"/>
               </a:rPr>
-              <a:t>github.com/ArseniiChan/canary</a:t>
+              <a:t>canary-psi.vercel.app/scan</a:t>
             </a:r>
             <a:pPr indent="0" marL="0">
               <a:buNone/>
             </a:pPr>
             <a:r>
-              <a:rPr lang="en-US" sz="1300" dirty="0">
+              <a:rPr lang="en-US" sz="1200" dirty="0">
                 <a:solidFill>
                   <a:srgbClr val="CFD8E8"/>
                 </a:solidFill>
@@ -8016,13 +8058,13 @@
                 <a:ea typeface="Calibri" pitchFamily="34" charset="-122"/>
                 <a:cs typeface="Calibri" pitchFamily="34" charset="-120"/>
               </a:rPr>
-              <a:t>       ·       Frozen spec tag:  </a:t>
+              <a:t>    ·    Code:  </a:t>
             </a:r>
             <a:pPr indent="0" marL="0">
               <a:buNone/>
             </a:pPr>
             <a:r>
-              <a:rPr lang="en-US" sz="1300" b="1" dirty="0">
+              <a:rPr lang="en-US" sz="1200" b="1" dirty="0">
                 <a:solidFill>
                   <a:srgbClr val="D4A017"/>
                 </a:solidFill>
@@ -8030,9 +8072,37 @@
                 <a:ea typeface="Calibri" pitchFamily="34" charset="-122"/>
                 <a:cs typeface="Calibri" pitchFamily="34" charset="-120"/>
               </a:rPr>
+              <a:t>github.com/ArseniiChan/canary</a:t>
+            </a:r>
+            <a:pPr indent="0" marL="0">
+              <a:buNone/>
+            </a:pPr>
+            <a:r>
+              <a:rPr lang="en-US" sz="1200" dirty="0">
+                <a:solidFill>
+                  <a:srgbClr val="CFD8E8"/>
+                </a:solidFill>
+                <a:latin typeface="Calibri" pitchFamily="34" charset="0"/>
+                <a:ea typeface="Calibri" pitchFamily="34" charset="-122"/>
+                <a:cs typeface="Calibri" pitchFamily="34" charset="-120"/>
+              </a:rPr>
+              <a:t>    ·    Tag:  </a:t>
+            </a:r>
+            <a:pPr indent="0" marL="0">
+              <a:buNone/>
+            </a:pPr>
+            <a:r>
+              <a:rPr lang="en-US" sz="1200" b="1" dirty="0">
+                <a:solidFill>
+                  <a:srgbClr val="D4A017"/>
+                </a:solidFill>
+                <a:latin typeface="Calibri" pitchFamily="34" charset="0"/>
+                <a:ea typeface="Calibri" pitchFamily="34" charset="-122"/>
+                <a:cs typeface="Calibri" pitchFamily="34" charset="-120"/>
+              </a:rPr>
               <a:t>validation-spec-frozen</a:t>
             </a:r>
-            <a:endParaRPr lang="en-US" sz="1300" dirty="0"/>
+            <a:endParaRPr lang="en-US" sz="1200" dirty="0"/>
           </a:p>
         </p:txBody>
       </p:sp>

</xml_diff>

<commit_message>
Deck v11: brighten accent blue from #0A279F to #3B82F6 for legibility on dark backgrounds
The template's logo-dot blue was too dark for text on the dark
background of slides 1 and 7. The template used dark blue for
graphic shapes (the giant ring), not for text — so dark-blue text
on near-black background was a contrast mistake.

Switched CANARY constant from #0A279F to #3B82F6 (Tailwind blue-500
equivalent). Same electric-blue family, much higher luminance.

Effect:
- Slide 1: 'CANARY' eyebrow, 'Trained:/Reused:/Tested:' labels,
  yellow rule are now clearly readable against the #141519
  background.
- Slide 7: 'CONCLUSION' eyebrow, 'Next experiment' eyebrow, URL
  accents now pop.
- Slides 3-6 (white surface): brighter blue still has good contrast
  on white; the change is forward-compatible.

No other changes.
</commit_message>
<xml_diff>
--- a/reports/canary_deck.pptx
+++ b/reports/canary_deck.pptx
@@ -1523,7 +1523,7 @@
             <a:r>
               <a:rPr lang="en-US" sz="1400" b="1" spc="1200" kern="0" dirty="0">
                 <a:solidFill>
-                  <a:srgbClr val="0A279F"/>
+                  <a:srgbClr val="3B82F6"/>
                 </a:solidFill>
                 <a:latin typeface="Calibri" pitchFamily="34" charset="0"/>
                 <a:ea typeface="Calibri" pitchFamily="34" charset="-122"/>
@@ -1612,11 +1612,11 @@
             <a:avLst/>
           </a:prstGeom>
           <a:solidFill>
-            <a:srgbClr val="0A279F"/>
+            <a:srgbClr val="3B82F6"/>
           </a:solidFill>
           <a:ln w="12700">
             <a:solidFill>
-              <a:srgbClr val="0A279F"/>
+              <a:srgbClr val="3B82F6"/>
             </a:solidFill>
             <a:prstDash val="solid"/>
           </a:ln>
@@ -1688,7 +1688,7 @@
             <a:r>
               <a:rPr lang="en-US" sz="1500" b="1" dirty="0">
                 <a:solidFill>
-                  <a:srgbClr val="0A279F"/>
+                  <a:srgbClr val="3B82F6"/>
                 </a:solidFill>
                 <a:latin typeface="Calibri" pitchFamily="34" charset="0"/>
                 <a:ea typeface="Calibri" pitchFamily="34" charset="-122"/>
@@ -1741,7 +1741,7 @@
             <a:r>
               <a:rPr lang="en-US" sz="1500" b="1" dirty="0">
                 <a:solidFill>
-                  <a:srgbClr val="0A279F"/>
+                  <a:srgbClr val="3B82F6"/>
                 </a:solidFill>
                 <a:latin typeface="Calibri" pitchFamily="34" charset="0"/>
                 <a:ea typeface="Calibri" pitchFamily="34" charset="-122"/>
@@ -1794,7 +1794,7 @@
             <a:r>
               <a:rPr lang="en-US" sz="1500" b="1" dirty="0">
                 <a:solidFill>
-                  <a:srgbClr val="0A279F"/>
+                  <a:srgbClr val="3B82F6"/>
                 </a:solidFill>
                 <a:latin typeface="Calibri" pitchFamily="34" charset="0"/>
                 <a:ea typeface="Calibri" pitchFamily="34" charset="-122"/>
@@ -2036,11 +2036,11 @@
             <a:avLst/>
           </a:prstGeom>
           <a:solidFill>
-            <a:srgbClr val="0A279F"/>
+            <a:srgbClr val="3B82F6"/>
           </a:solidFill>
           <a:ln w="12700">
             <a:solidFill>
-              <a:srgbClr val="0A279F"/>
+              <a:srgbClr val="3B82F6"/>
             </a:solidFill>
             <a:prstDash val="solid"/>
           </a:ln>
@@ -2073,7 +2073,7 @@
             <a:r>
               <a:rPr lang="en-US" sz="11000" dirty="0">
                 <a:solidFill>
-                  <a:srgbClr val="0A279F"/>
+                  <a:srgbClr val="3B82F6"/>
                 </a:solidFill>
                 <a:latin typeface="Georgia" pitchFamily="34" charset="0"/>
                 <a:ea typeface="Georgia" pitchFamily="34" charset="-122"/>
@@ -2142,11 +2142,11 @@
             <a:avLst/>
           </a:prstGeom>
           <a:solidFill>
-            <a:srgbClr val="0A279F"/>
+            <a:srgbClr val="3B82F6"/>
           </a:solidFill>
           <a:ln w="12700">
             <a:solidFill>
-              <a:srgbClr val="0A279F"/>
+              <a:srgbClr val="3B82F6"/>
             </a:solidFill>
             <a:prstDash val="solid"/>
           </a:ln>
@@ -2397,11 +2397,11 @@
             <a:avLst/>
           </a:prstGeom>
           <a:solidFill>
-            <a:srgbClr val="0A279F"/>
+            <a:srgbClr val="3B82F6"/>
           </a:solidFill>
           <a:ln w="12700">
             <a:solidFill>
-              <a:srgbClr val="0A279F"/>
+              <a:srgbClr val="3B82F6"/>
             </a:solidFill>
             <a:prstDash val="solid"/>
           </a:ln>
@@ -2537,7 +2537,7 @@
             <a:r>
               <a:rPr lang="en-US" sz="1100" b="1" spc="300" kern="0" dirty="0">
                 <a:solidFill>
-                  <a:srgbClr val="0A279F"/>
+                  <a:srgbClr val="3B82F6"/>
                 </a:solidFill>
                 <a:latin typeface="Calibri" pitchFamily="34" charset="0"/>
                 <a:ea typeface="Calibri" pitchFamily="34" charset="-122"/>
@@ -2564,11 +2564,11 @@
             <a:avLst/>
           </a:prstGeom>
           <a:solidFill>
-            <a:srgbClr val="0A279F"/>
+            <a:srgbClr val="3B82F6"/>
           </a:solidFill>
           <a:ln w="12700">
             <a:solidFill>
-              <a:srgbClr val="0A279F"/>
+              <a:srgbClr val="3B82F6"/>
             </a:solidFill>
             <a:prstDash val="solid"/>
           </a:ln>
@@ -2668,7 +2668,7 @@
             <a:r>
               <a:rPr lang="en-US" sz="1100" b="1" spc="300" kern="0" dirty="0">
                 <a:solidFill>
-                  <a:srgbClr val="0A279F"/>
+                  <a:srgbClr val="3B82F6"/>
                 </a:solidFill>
                 <a:latin typeface="Calibri" pitchFamily="34" charset="0"/>
                 <a:ea typeface="Calibri" pitchFamily="34" charset="-122"/>
@@ -2695,11 +2695,11 @@
             <a:avLst/>
           </a:prstGeom>
           <a:solidFill>
-            <a:srgbClr val="0A279F"/>
+            <a:srgbClr val="3B82F6"/>
           </a:solidFill>
           <a:ln w="12700">
             <a:solidFill>
-              <a:srgbClr val="0A279F"/>
+              <a:srgbClr val="3B82F6"/>
             </a:solidFill>
             <a:prstDash val="solid"/>
           </a:ln>
@@ -2799,7 +2799,7 @@
             <a:r>
               <a:rPr lang="en-US" sz="1100" b="1" spc="300" kern="0" dirty="0">
                 <a:solidFill>
-                  <a:srgbClr val="0A279F"/>
+                  <a:srgbClr val="3B82F6"/>
                 </a:solidFill>
                 <a:latin typeface="Calibri" pitchFamily="34" charset="0"/>
                 <a:ea typeface="Calibri" pitchFamily="34" charset="-122"/>
@@ -2826,11 +2826,11 @@
             <a:avLst/>
           </a:prstGeom>
           <a:solidFill>
-            <a:srgbClr val="0A279F"/>
+            <a:srgbClr val="3B82F6"/>
           </a:solidFill>
           <a:ln w="12700">
             <a:solidFill>
-              <a:srgbClr val="0A279F"/>
+              <a:srgbClr val="3B82F6"/>
             </a:solidFill>
             <a:prstDash val="solid"/>
           </a:ln>
@@ -3191,11 +3191,11 @@
             <a:avLst/>
           </a:prstGeom>
           <a:solidFill>
-            <a:srgbClr val="0A279F"/>
+            <a:srgbClr val="3B82F6"/>
           </a:solidFill>
           <a:ln w="12700">
             <a:solidFill>
-              <a:srgbClr val="0A279F"/>
+              <a:srgbClr val="3B82F6"/>
             </a:solidFill>
             <a:prstDash val="solid"/>
           </a:ln>
@@ -5134,11 +5134,11 @@
             <a:avLst/>
           </a:prstGeom>
           <a:solidFill>
-            <a:srgbClr val="0A279F"/>
+            <a:srgbClr val="3B82F6"/>
           </a:solidFill>
           <a:ln w="12700">
             <a:solidFill>
-              <a:srgbClr val="0A279F"/>
+              <a:srgbClr val="3B82F6"/>
             </a:solidFill>
             <a:prstDash val="solid"/>
           </a:ln>
@@ -5452,11 +5452,11 @@
             <a:avLst/>
           </a:prstGeom>
           <a:solidFill>
-            <a:srgbClr val="0A279F"/>
+            <a:srgbClr val="3B82F6"/>
           </a:solidFill>
           <a:ln w="12700">
             <a:solidFill>
-              <a:srgbClr val="0A279F"/>
+              <a:srgbClr val="3B82F6"/>
             </a:solidFill>
             <a:prstDash val="solid"/>
           </a:ln>
@@ -5502,11 +5502,11 @@
             <a:avLst/>
           </a:prstGeom>
           <a:solidFill>
-            <a:srgbClr val="0A279F"/>
+            <a:srgbClr val="3B82F6"/>
           </a:solidFill>
           <a:ln w="12700">
             <a:solidFill>
-              <a:srgbClr val="0A279F"/>
+              <a:srgbClr val="3B82F6"/>
             </a:solidFill>
             <a:prstDash val="solid"/>
           </a:ln>
@@ -5539,7 +5539,7 @@
             <a:r>
               <a:rPr lang="en-US" sz="1800" b="1" dirty="0">
                 <a:solidFill>
-                  <a:srgbClr val="0A279F"/>
+                  <a:srgbClr val="3B82F6"/>
                 </a:solidFill>
                 <a:latin typeface="Georgia" pitchFamily="34" charset="0"/>
                 <a:ea typeface="Georgia" pitchFamily="34" charset="-122"/>
@@ -5672,11 +5672,11 @@
             <a:avLst/>
           </a:prstGeom>
           <a:solidFill>
-            <a:srgbClr val="0A279F"/>
+            <a:srgbClr val="3B82F6"/>
           </a:solidFill>
           <a:ln w="12700">
             <a:solidFill>
-              <a:srgbClr val="0A279F"/>
+              <a:srgbClr val="3B82F6"/>
             </a:solidFill>
             <a:prstDash val="solid"/>
           </a:ln>
@@ -5709,7 +5709,7 @@
             <a:r>
               <a:rPr lang="en-US" sz="1800" b="1" dirty="0">
                 <a:solidFill>
-                  <a:srgbClr val="0A279F"/>
+                  <a:srgbClr val="3B82F6"/>
                 </a:solidFill>
                 <a:latin typeface="Georgia" pitchFamily="34" charset="0"/>
                 <a:ea typeface="Georgia" pitchFamily="34" charset="-122"/>
@@ -5842,11 +5842,11 @@
             <a:avLst/>
           </a:prstGeom>
           <a:solidFill>
-            <a:srgbClr val="0A279F"/>
+            <a:srgbClr val="3B82F6"/>
           </a:solidFill>
           <a:ln w="12700">
             <a:solidFill>
-              <a:srgbClr val="0A279F"/>
+              <a:srgbClr val="3B82F6"/>
             </a:solidFill>
             <a:prstDash val="solid"/>
           </a:ln>
@@ -5879,7 +5879,7 @@
             <a:r>
               <a:rPr lang="en-US" sz="1800" b="1" dirty="0">
                 <a:solidFill>
-                  <a:srgbClr val="0A279F"/>
+                  <a:srgbClr val="3B82F6"/>
                 </a:solidFill>
                 <a:latin typeface="Georgia" pitchFamily="34" charset="0"/>
                 <a:ea typeface="Georgia" pitchFamily="34" charset="-122"/>
@@ -6109,7 +6109,7 @@
             <a:r>
               <a:rPr lang="en-US" sz="1200" b="1" spc="400" kern="0" dirty="0">
                 <a:solidFill>
-                  <a:srgbClr val="0A279F"/>
+                  <a:srgbClr val="3B82F6"/>
                 </a:solidFill>
                 <a:latin typeface="Calibri" pitchFamily="34" charset="0"/>
                 <a:ea typeface="Calibri" pitchFamily="34" charset="-122"/>
@@ -6136,11 +6136,11 @@
             <a:avLst/>
           </a:prstGeom>
           <a:solidFill>
-            <a:srgbClr val="0A279F"/>
+            <a:srgbClr val="3B82F6"/>
           </a:solidFill>
           <a:ln w="12700">
             <a:solidFill>
-              <a:srgbClr val="0A279F"/>
+              <a:srgbClr val="3B82F6"/>
             </a:solidFill>
             <a:prstDash val="solid"/>
           </a:ln>
@@ -6293,7 +6293,7 @@
             <a:r>
               <a:rPr lang="en-US" sz="1200" b="1" spc="400" kern="0" dirty="0">
                 <a:solidFill>
-                  <a:srgbClr val="0A279F"/>
+                  <a:srgbClr val="3B82F6"/>
                 </a:solidFill>
                 <a:latin typeface="Calibri" pitchFamily="34" charset="0"/>
                 <a:ea typeface="Calibri" pitchFamily="34" charset="-122"/>
@@ -6320,11 +6320,11 @@
             <a:avLst/>
           </a:prstGeom>
           <a:solidFill>
-            <a:srgbClr val="0A279F"/>
+            <a:srgbClr val="3B82F6"/>
           </a:solidFill>
           <a:ln w="12700">
             <a:solidFill>
-              <a:srgbClr val="0A279F"/>
+              <a:srgbClr val="3B82F6"/>
             </a:solidFill>
             <a:prstDash val="solid"/>
           </a:ln>
@@ -6476,7 +6476,7 @@
             <a:r>
               <a:rPr lang="en-US" sz="1200" b="1" dirty="0">
                 <a:solidFill>
-                  <a:srgbClr val="0A279F"/>
+                  <a:srgbClr val="3B82F6"/>
                 </a:solidFill>
                 <a:latin typeface="Calibri" pitchFamily="34" charset="0"/>
                 <a:ea typeface="Calibri" pitchFamily="34" charset="-122"/>
@@ -6529,7 +6529,7 @@
             <a:r>
               <a:rPr lang="en-US" sz="1200" b="1" dirty="0">
                 <a:solidFill>
-                  <a:srgbClr val="0A279F"/>
+                  <a:srgbClr val="3B82F6"/>
                 </a:solidFill>
                 <a:latin typeface="Calibri" pitchFamily="34" charset="0"/>
                 <a:ea typeface="Calibri" pitchFamily="34" charset="-122"/>
@@ -6557,7 +6557,7 @@
             <a:r>
               <a:rPr lang="en-US" sz="1200" b="1" dirty="0">
                 <a:solidFill>
-                  <a:srgbClr val="0A279F"/>
+                  <a:srgbClr val="3B82F6"/>
                 </a:solidFill>
                 <a:latin typeface="Calibri" pitchFamily="34" charset="0"/>
                 <a:ea typeface="Calibri" pitchFamily="34" charset="-122"/>

</xml_diff>

<commit_message>
Deck v16: strip speaker notes to pure spoken text
Removed everything that wasn't part of what the speaker actually
says aloud:
- TARGET time markers (0:25, 0:45, etc.)
- SAY: headers and surrounding quotation marks
- (Pause. Click to slide N.) cues
- [point at chart] / [point at Lehman row] inline action cues
- STAGE NOTES blocks (don't say 'honestly', the kill line is
  the 1995 framing, etc.)
- Slide 7's appendix material (time-target table, Q&A fallback
  line, if-running-long cuts list)

Each slide's notes panel now contains only the words the speaker
will say, in order. Reading word-for-word from the panel produces
the talk.

The stage cues, timing targets, and tactical advice that lived in
the previous notes still exist in reports/speaker_notes.md (the
standalone markdown file) for rehearsal use. The pptx notes panel
is now optimized for live delivery, not rehearsal.
</commit_message>
<xml_diff>
--- a/reports/canary_deck.pptx
+++ b/reports/canary_deck.pptx
@@ -508,14 +508,7 @@
           <a:p>
             <a:r>
               <a:rPr lang="en-US" dirty="0"/>
-              <a:t>TARGET: 0:25.
-SAY:
-"I'm Arsenii Chan. The question I built this project around is simple. Do companies committing accounting fraud write their annual reports differently from honest companies? And can a machine learning model spot the difference? Six famous fraud cases. One test. Let me show you what came back."
-(Pause. Click to slide 2.)
-STAGE NOTES:
-- Don't announce the conclusion. Don't say "honestly" or "negative result"; both pre-spoil the talk.
-- Open with the question. The audience leans forward.
-- The slide shows the first half of the question. You verbally complete it ("and can a model spot the difference"). Audience reads while you fill in the rest.</a:t>
+              <a:t>I'm Arsenii Chan. The question I built this project around is simple. Do companies committing accounting fraud write their annual reports differently from honest companies? And can a machine learning model spot the difference? Six famous fraud cases. One test. Let me show you what came back.</a:t>
             </a:r>
             <a:endParaRPr lang="en-US" dirty="0"/>
           </a:p>
@@ -603,17 +596,9 @@
           <a:p>
             <a:r>
               <a:rPr lang="en-US" dirty="0"/>
-              <a:t>TARGET: 0:45.
-SAY:
-"Six historical fraud cases: Enron, WorldCom, Tyco, HealthSouth, Valeant, Lehman Brothers. Each one turned out to be misrepresenting its finances at the time it filed this report. The SEC or class-action lawsuits exposed them years later. Each cost investors over a billion dollars. I paired each fraud filing against companies in the same industry, same year, that were clean.
-The model never sees the word 'fraud' during training. It just reads the long prose section of each annual report (where management explains the year in their own words) and learns what 'normal' looks like, industry by industry. Then it ranks the unusual filings against their peers.
-[point at pull-quote] The formal question is on the slide. [point at the answer line] The plain-English answer is right below it. I'll spend the rest of the talk on the evidence."
-(Click to slide 3.)
-STAGE NOTES:
-- Don't read the pull-quote out loud. It's the formal academic version. The audience reads while you point.
-- Pointing is faster than reading.
-- Don't say MD&amp;A out loud. The phrase "long prose section where management explains the year" replaces it.
-- The context about the six companies being multi-billion-dollar frauds is critical. The audience needs to know these names matter before reaching slide 4. Don't skip it.</a:t>
+              <a:t>Six historical fraud cases: Enron, WorldCom, Tyco, HealthSouth, Valeant, Lehman Brothers. Each one turned out to be misrepresenting its finances at the time it filed this report. The SEC or class-action lawsuits exposed them years later. Each cost investors over a billion dollars. I paired each fraud filing against companies in the same industry, same year, that were clean.
+The model never sees the word 'fraud' during training. It just reads the long prose section of each annual report, where management explains the year in their own words, and learns what 'normal' looks like, industry by industry. Then it ranks the unusual filings against their peers.
+The formal question is on the slide. The plain-English answer is right below it. I'll spend the rest of the talk on the evidence.</a:t>
             </a:r>
             <a:endParaRPr lang="en-US" dirty="0"/>
           </a:p>
@@ -701,19 +686,12 @@
           <a:p>
             <a:r>
               <a:rPr lang="en-US" dirty="0"/>
-              <a:t>TARGET: 0:50. THIS IS THE MOST IMPORTANT SLIDE. SLOW DOWN.
-SAY:
-"Before I show you any number, I want to walk through the methodology. It's what makes the result mean anything.
-Three rules I locked in BEFORE I ran the test. [point at columns]
-One: the model never sees a fraud during training. For each fraud case, the model trains only on clean filings from OTHER cases. The fraud I'm testing is held out.
-Two: the model never sees the future. Within that training set, only filings dated on or before the fraud's filing date are allowed. The model can't pick up language that came out AFTER the fraud was discovered.
-Three: single pass, no tuning. The architecture, the hyperparameters, the test set: all of that was written down and locked into the repo BEFORE the test ran. [point at git-tag panel] Top right shows the actual lock. Committed and tagged on May 1st, before any result came in.
-Test ran once. Whatever it said, that's the result."
-(Click to slide 4.)
-STAGE NOTES:
-- The git-tag panel is small. Say "top right shows" rather than gesturing at the podium.
-- If anyone in the room knows what pre-registration is, this is where you've already won them over.
-- Don't say "LOCO" or "MiniLM" aloud. The slide shows them; you say "leave-one-out" or "the embedding model" if you need to.</a:t>
+              <a:t>Before I show you any number, I want to walk through the methodology. It's what makes the result mean anything.
+Three rules I locked in before I ran the test.
+One: the model never sees a fraud during training. For each fraud case, the model trains only on clean filings from other cases. The fraud I'm testing is held out.
+Two: the model never sees the future. Within that training set, only filings dated on or before the fraud's filing date are allowed. The model can't pick up language that came out after the fraud was discovered.
+Three: single pass, no tuning. The architecture, the hyperparameters, the test set: all of that was written down and locked into the repo before the test ran. Top right shows the actual lock. Committed and tagged on May 1st, before any result came in.
+Test ran once. Whatever it said, that's the result.</a:t>
             </a:r>
             <a:endParaRPr lang="en-US" dirty="0"/>
           </a:p>
@@ -801,18 +779,11 @@
           <a:p>
             <a:r>
               <a:rPr lang="en-US" dirty="0"/>
-              <a:t>TARGET: 1:00.
-SAY:
-"Here's what came back. Five cases I could test, one excluded. I'll come back to the excluded one.
-[point at Lehman row] Only Lehman, the investment bank whose collapse triggered the 2008 financial crisis, lands in the top three within its peer group. Three out of thirteen. The statistical test is highly significant, but the effect size is small [point at warning glyph]. Both numbers matter. Reporting either one alone would be misleading. And as you'll see on the next slide, even on Lehman, a 1990s baseline beats my model.
-[quick scan with hand] The other four (HealthSouth, Valeant, Tyco, WorldCom) all rank no better than random. The test actually goes in the OPPOSITE direction from what we'd want. Overall my hit rates are at or below random.
-Now, Enron. [point at italicized row] Enron's filing date is April 2nd, 2001. Every other peer in every other case was dated later. Under the strict rule I locked in, there's no clean filing Enron could have trained on.
-So I had a choice. Relax the rule and rerun, or report the exclusion. I reported the exclusion. The pre-registered design was infeasible for Enron, and I didn't catch that before I locked the spec. That's a finding about pre-registration, not about fraud detection."
-(Click to slide 5.)
-STAGE NOTES:
-- Hands ON the slide. Don't quote numbers from memory; point at them on the projection.
-- The forward-pointer ("a 1990s baseline beats my model") is critical. If a listener tunes out during slide 5, they need to walk away with this on slide 4. Don't skip it.
-- The Enron exclusion is the most likely Q&amp;A target. Pre-empt it: "I had a choice. Relax the rule, or report the exclusion. I reported the exclusion."</a:t>
+              <a:t>Here's what came back. Five cases I could test, one excluded. I'll come back to the excluded one.
+Only Lehman, the investment bank whose collapse triggered the 2008 financial crisis, lands in the top three within its peer group. Three out of thirteen. The statistical test is highly significant, but the effect size is small. Both numbers matter. Reporting either one alone would be misleading. And as you'll see on the next slide, even on Lehman, a 1990s baseline beats my model.
+The other four (HealthSouth, Valeant, Tyco, WorldCom) all rank no better than random. The test actually goes in the opposite direction from what we'd want. Overall my hit rates are at or below random.
+Now, Enron. Enron's filing date is April 2nd, 2001. Every other peer in every other case was dated later. Under the strict rule I locked in, there's no clean filing Enron could have trained on.
+So I had a choice. Relax the rule and rerun, or report the exclusion. I reported the exclusion. The pre-registered design was infeasible for Enron, and I didn't catch that before I locked the spec. That's a finding about pre-registration, not about fraud detection.</a:t>
             </a:r>
             <a:endParaRPr lang="en-US" dirty="0"/>
           </a:p>
@@ -900,22 +871,14 @@
           <a:p>
             <a:r>
               <a:rPr lang="en-US" dirty="0"/>
-              <a:t>TARGET: 1:10. THIS IS THE LEDE OF THE TALK. DON'T RUSH.
-SAY:
-"Now the part I think actually matters.
+              <a:t>Now the part I think actually matters.
 After the test ran, I asked myself the question every machine-learning paper should answer and most don't. Would a method from before I was born produce the same result?
-So I ran one. [point at chart] A simple word-counting method. The kind of thing you could have written in 1995 from a textbook. Same training data, same statistical tests, same pipeline shape. No neural network. No transformer.
-[point at chart] On four of five cases, the 1995 method TIES the modern one. [point at Lehman bar] And on Lehman, the one case the modern method got, the 1995 method gets it BETTER. The statistical test is way more confident.
+So I ran one. A simple word-counting method. The kind of thing you could have written in 1995 from a textbook. Same training data, same statistical tests, same pipeline shape. No neural network. No transformer.
+On four of five cases, the 1995 method ties the modern one. And on Lehman, the one case the modern method got, the 1995 method gets it better. The statistical test is way more confident.
 Let me say what I'm not saying, and then what I am saying.
-I am NOT saying the modern method is broken, or that neural networks are useless for this kind of problem.
-I AM saying that on these five cases, with the rules I locked in, the modern method did not beat a method I could have run in 1995.
-If you take one thing from this talk, this is it. A sharp baseline isn't optional. A result that loses to a baseline isn't evidence for the neural model."
-(Click to slide 6.)
-STAGE NOTES:
-- The "before I was born" / "1995" framing is the kill line. Practice deadpan delivery.
-- If the room is silent after, that's fine. Keep going.
-- The "I am not saying / I am saying" structure prevents the misread "the AI didn't work."
-- Don't say "TF-IDF" or "truncated SVD" aloud unless someone asks. "1995 method" or "simple word-counting method" is the spoken phrase.</a:t>
+I am not saying the modern method is broken, or that neural networks are useless for this kind of problem.
+I am saying that on these five cases, with the rules I locked in, the modern method did not beat a method I could have run in 1995.
+If you take one thing from this talk, this is it. A sharp baseline isn't optional. A result that loses to a baseline isn't evidence for the neural model.</a:t>
             </a:r>
             <a:endParaRPr lang="en-US" dirty="0"/>
           </a:p>
@@ -1003,18 +966,10 @@
           <a:p>
             <a:r>
               <a:rPr lang="en-US" dirty="0"/>
-              <a:t>TARGET: 0:40. SPEED.
-SAY:
-"Three questions I expect, with quick answers so we have time for whatever else you actually want to ask.
+              <a:t>Three questions I expect, with quick answers so we have time for whatever else you actually want to ask.
 Did you check a trivial baseline? Yes. Same training data, same compression. The 1995 baseline matches or beats the modern method on every case. The honest claim is that the modern method adds nothing here. Slide 5.
 The baseline is post-hoc, isn't that HARKing? The pre-registered hypothesis was about the modern method, and I report that result unchanged. The 1995 baseline was added after seeing the null result, and I label it as post-hoc. The main result doesn't depend on the baseline.
-Could the embedding model have memorized 'Lehman' or 'Repo 105'? I tested that. I replaced 93 of those words in Lehman's filing with a placeholder and re-scored. Lehman's rank held at 3 out of 13. So the model isn't just spotting the word 'Lehman.'"
-(Click to slide 7.)
-STAGE NOTES:
-- Three Q&amp;As live on slide. The Enron exclusion question is best handled in actual Q&amp;A if asked (already covered on slide 4).
-- Don't try to deliver all three under pressure if you're running long. Two minimum.
-- If asked about supervised classifier: "At six fraud examples a supervised classifier overfits trivially. Future work."
-- If asked about the parser: "Five failures are pre-2001 peer filings. All six fraud filings parsed at 100%."</a:t>
+Could the embedding model have memorized 'Lehman' or 'Repo 105'? I tested that. I replaced 93 of those words in Lehman's filing with a placeholder and re-scored. Lehman's rank held at 3 out of 13. So the model isn't just spotting the word 'Lehman.'</a:t>
             </a:r>
             <a:endParaRPr lang="en-US" dirty="0"/>
           </a:p>
@@ -1102,31 +1057,13 @@
           <a:p>
             <a:r>
               <a:rPr lang="en-US" dirty="0"/>
-              <a:t>TARGET: 0:50. LAND THE URLs CLEANLY. PAUSE ONE BEAT AFTER "THANKS."
-SAY:
-"Two takeaways and one next step.
+              <a:t>Two takeaways and one next step.
 What survived: pre-registration. The contract held. I didn't tweak the model, I didn't redefine 'clean,' I didn't backtrack on the Enron exclusion when the result got uncomfortable.
 What failed: the modern method, beyond what the 1990s baseline already does. A result that loses to a baseline is not evidence for the neural model.
-What I'd do differently: make sure every held-out fraud actually has training data under the rule, BEFORE freezing the spec. Enron was unevaluable under my own rule, and I didn't catch it until validation ran.
-Next experiment: same model, same filings, but compare each company against ITSELF across years, instead of against industry peers. That's the next step this study couldn't run.
-[point at footer] Try the pipeline at the link below. Paste any annual report and see how it scores against the five fraud cases. Code is on GitHub. The frozen-spec git tag is in the repo.
-Thanks. Happy to take questions."
-(End. Open Q&amp;A.)
-STAGE NOTES:
-- Pause for ONE beat after "Thanks." Don't run into the next sentence.
-- Look UP at the audience for the URL line. That's the call-to-action.
-- If you've delivered slides 1 through 7 cleanly, your face should look calm.
-Q&amp;A FALLBACK LINE if you don't know an answer:
-"That's a real gap I haven't characterized. Let me follow up after the talk."
-Don't fake numbers under pressure. "I don't know" is graduate-school behavior, not weakness.
-TIME TARGETS:
-Slide 1: 0:25  |  Slide 2: 0:45  |  Slide 3: 0:50  |  Slide 4: 1:00
-Slide 5: 1:10  |  Slide 6: 0:40  |  Slide 7: 0:45
-Total target: 5:35.  Hard ceiling: 6:55.  Buffer: 1:25.
-IF RUNNING LONG, CUTS:
-- Drop "I am not saying / I am saying" on Slide 5 (saves 15 seconds)
-- Skip third Q&amp;A on Slide 6 (saves 15 seconds)
-- Skip next-experiment line on Slide 7 (saves 10 seconds)</a:t>
+What I'd do differently: make sure every held-out fraud actually has training data under the rule, before freezing the spec. Enron was unevaluable under my own rule, and I didn't catch it until validation ran.
+Next experiment: same model, same filings, but compare each company against itself across years, instead of against industry peers. That's the next step this study couldn't run.
+Try the pipeline at the link below. Paste any annual report and see how it scores against the five fraud cases. Code is on GitHub. The frozen-spec git tag is in the repo.
+Thanks. Happy to take questions.</a:t>
             </a:r>
             <a:endParaRPr lang="en-US" dirty="0"/>
           </a:p>

</xml_diff>